<commit_message>
Add bench-session photos to the deck and repository
Co-Authored-By: Claude Opus 5.5 <noreply@anthropic.com>
</commit_message>
<xml_diff>
--- a/docs/Hydra_Nexus_Vishwakarma_Stage2_Submission.pptx
+++ b/docs/Hydra_Nexus_Vishwakarma_Stage2_Submission.pptx
@@ -32768,8 +32768,8 @@
         </p:nvSpPr>
         <p:spPr>
           <a:xfrm>
-            <a:off x="265175" y="1737360"/>
-            <a:ext cx="1207008" cy="548640"/>
+            <a:off x="320040" y="1737360"/>
+            <a:ext cx="1097280" cy="548640"/>
           </a:xfrm>
           <a:prstGeom prst="rect">
             <a:avLst/>
@@ -32787,7 +32787,7 @@
               <a:buNone/>
             </a:pPr>
             <a:r>
-              <a:rPr sz="800" b="0" i="0">
+              <a:rPr sz="750" b="0" i="0">
                 <a:solidFill>
                   <a:srgbClr val="0F172A"/>
                 </a:solidFill>
@@ -32806,7 +32806,7 @@
         </p:nvSpPr>
         <p:spPr>
           <a:xfrm>
-            <a:off x="2021967" y="1325880"/>
+            <a:off x="1876552" y="1325880"/>
             <a:ext cx="310896" cy="310896"/>
           </a:xfrm>
           <a:prstGeom prst="ellipse">
@@ -32865,8 +32865,8 @@
         </p:nvSpPr>
         <p:spPr>
           <a:xfrm>
-            <a:off x="1573911" y="1737360"/>
-            <a:ext cx="1207008" cy="548640"/>
+            <a:off x="1483360" y="1737360"/>
+            <a:ext cx="1097280" cy="548640"/>
           </a:xfrm>
           <a:prstGeom prst="rect">
             <a:avLst/>
@@ -32884,7 +32884,7 @@
               <a:buNone/>
             </a:pPr>
             <a:r>
-              <a:rPr sz="800" b="0" i="0">
+              <a:rPr sz="750" b="0" i="0">
                 <a:solidFill>
                   <a:srgbClr val="0F172A"/>
                 </a:solidFill>
@@ -32903,7 +32903,7 @@
         </p:nvSpPr>
         <p:spPr>
           <a:xfrm>
-            <a:off x="3330702" y="1325880"/>
+            <a:off x="3039872" y="1325880"/>
             <a:ext cx="310896" cy="310896"/>
           </a:xfrm>
           <a:prstGeom prst="ellipse">
@@ -32962,8 +32962,8 @@
         </p:nvSpPr>
         <p:spPr>
           <a:xfrm>
-            <a:off x="2882646" y="1737360"/>
-            <a:ext cx="1207008" cy="548640"/>
+            <a:off x="2646680" y="1737360"/>
+            <a:ext cx="1097280" cy="548640"/>
           </a:xfrm>
           <a:prstGeom prst="rect">
             <a:avLst/>
@@ -32981,7 +32981,7 @@
               <a:buNone/>
             </a:pPr>
             <a:r>
-              <a:rPr sz="800" b="0" i="0">
+              <a:rPr sz="750" b="0" i="0">
                 <a:solidFill>
                   <a:srgbClr val="0F172A"/>
                 </a:solidFill>
@@ -33000,7 +33000,7 @@
         </p:nvSpPr>
         <p:spPr>
           <a:xfrm>
-            <a:off x="4639437" y="1325880"/>
+            <a:off x="4203192" y="1325880"/>
             <a:ext cx="310896" cy="310896"/>
           </a:xfrm>
           <a:prstGeom prst="ellipse">
@@ -33059,8 +33059,8 @@
         </p:nvSpPr>
         <p:spPr>
           <a:xfrm>
-            <a:off x="4191381" y="1737360"/>
-            <a:ext cx="1207008" cy="548640"/>
+            <a:off x="3810000" y="1737360"/>
+            <a:ext cx="1097280" cy="548640"/>
           </a:xfrm>
           <a:prstGeom prst="rect">
             <a:avLst/>
@@ -33078,7 +33078,7 @@
               <a:buNone/>
             </a:pPr>
             <a:r>
-              <a:rPr sz="800" b="0" i="0">
+              <a:rPr sz="750" b="0" i="0">
                 <a:solidFill>
                   <a:srgbClr val="0F172A"/>
                 </a:solidFill>
@@ -33097,7 +33097,7 @@
         </p:nvSpPr>
         <p:spPr>
           <a:xfrm>
-            <a:off x="5948172" y="1325880"/>
+            <a:off x="5366512" y="1325880"/>
             <a:ext cx="310896" cy="310896"/>
           </a:xfrm>
           <a:prstGeom prst="ellipse">
@@ -33156,8 +33156,8 @@
         </p:nvSpPr>
         <p:spPr>
           <a:xfrm>
-            <a:off x="5500116" y="1737360"/>
-            <a:ext cx="1207008" cy="548640"/>
+            <a:off x="4973320" y="1737360"/>
+            <a:ext cx="1097280" cy="548640"/>
           </a:xfrm>
           <a:prstGeom prst="rect">
             <a:avLst/>
@@ -33175,7 +33175,7 @@
               <a:buNone/>
             </a:pPr>
             <a:r>
-              <a:rPr sz="800" b="0" i="0">
+              <a:rPr sz="750" b="0" i="0">
                 <a:solidFill>
                   <a:srgbClr val="0F172A"/>
                 </a:solidFill>
@@ -33194,7 +33194,104 @@
         </p:nvSpPr>
         <p:spPr>
           <a:xfrm>
-            <a:off x="7256907" y="1325880"/>
+            <a:off x="6529832" y="1325880"/>
+            <a:ext cx="310896" cy="310896"/>
+          </a:xfrm>
+          <a:prstGeom prst="ellipse">
+            <a:avLst/>
+          </a:prstGeom>
+          <a:solidFill>
+            <a:srgbClr val="059668"/>
+          </a:solidFill>
+          <a:ln w="19050">
+            <a:solidFill>
+              <a:srgbClr val="059668"/>
+            </a:solidFill>
+          </a:ln>
+          <a:effectLst/>
+        </p:spPr>
+        <p:style>
+          <a:lnRef idx="1">
+            <a:schemeClr val="accent1"/>
+          </a:lnRef>
+          <a:fillRef idx="3">
+            <a:schemeClr val="accent1"/>
+          </a:fillRef>
+          <a:effectRef idx="2">
+            <a:schemeClr val="accent1"/>
+          </a:effectRef>
+          <a:fontRef idx="minor">
+            <a:schemeClr val="lt1"/>
+          </a:fontRef>
+        </p:style>
+        <p:txBody>
+          <a:bodyPr rtlCol="0" anchor="ctr" wrap="square" lIns="0" rIns="0" tIns="27432" bIns="27432"/>
+          <a:lstStyle/>
+          <a:p>
+            <a:pPr algn="ctr">
+              <a:spcAft>
+                <a:spcPts val="0"/>
+              </a:spcAft>
+            </a:pPr>
+            <a:r>
+              <a:rPr sz="800" b="1" i="0">
+                <a:solidFill>
+                  <a:srgbClr val="FFFFFF"/>
+                </a:solidFill>
+                <a:latin typeface="Arial"/>
+              </a:rPr>
+              <a:t>6</a:t>
+            </a:r>
+          </a:p>
+        </p:txBody>
+      </p:sp>
+      <p:sp>
+        <p:nvSpPr>
+          <p:cNvPr id="19" name="TextBox 18"/>
+          <p:cNvSpPr txBox="1"/>
+          <p:nvPr/>
+        </p:nvSpPr>
+        <p:spPr>
+          <a:xfrm>
+            <a:off x="6136640" y="1737360"/>
+            <a:ext cx="1097280" cy="548640"/>
+          </a:xfrm>
+          <a:prstGeom prst="rect">
+            <a:avLst/>
+          </a:prstGeom>
+          <a:noFill/>
+        </p:spPr>
+        <p:txBody>
+          <a:bodyPr wrap="square" lIns="0" rIns="0" tIns="0" bIns="0" anchor="t"/>
+          <a:lstStyle/>
+          <a:p>
+            <a:pPr algn="ctr">
+              <a:spcAft>
+                <a:spcPts val="300"/>
+              </a:spcAft>
+              <a:buNone/>
+            </a:pPr>
+            <a:r>
+              <a:rPr sz="750" b="0" i="0">
+                <a:solidFill>
+                  <a:srgbClr val="0F172A"/>
+                </a:solidFill>
+                <a:latin typeface="Arial"/>
+              </a:rPr>
+              <a:t>Wired the sensors on a bench</a:t>
+            </a:r>
+          </a:p>
+        </p:txBody>
+      </p:sp>
+      <p:sp>
+        <p:nvSpPr>
+          <p:cNvPr id="20" name="Oval 19"/>
+          <p:cNvSpPr/>
+          <p:nvPr/>
+        </p:nvSpPr>
+        <p:spPr>
+          <a:xfrm>
+            <a:off x="7693152" y="1325880"/>
             <a:ext cx="310896" cy="310896"/>
           </a:xfrm>
           <a:prstGeom prst="ellipse">
@@ -33240,21 +33337,21 @@
                 </a:solidFill>
                 <a:latin typeface="Arial"/>
               </a:rPr>
-              <a:t>6</a:t>
+              <a:t>7</a:t>
             </a:r>
           </a:p>
         </p:txBody>
       </p:sp>
       <p:sp>
         <p:nvSpPr>
-          <p:cNvPr id="19" name="TextBox 18"/>
+          <p:cNvPr id="21" name="TextBox 20"/>
           <p:cNvSpPr txBox="1"/>
           <p:nvPr/>
         </p:nvSpPr>
         <p:spPr>
           <a:xfrm>
-            <a:off x="6808851" y="1737360"/>
-            <a:ext cx="1207008" cy="548640"/>
+            <a:off x="7299960" y="1737360"/>
+            <a:ext cx="1097280" cy="548640"/>
           </a:xfrm>
           <a:prstGeom prst="rect">
             <a:avLst/>
@@ -33272,7 +33369,7 @@
               <a:buNone/>
             </a:pPr>
             <a:r>
-              <a:rPr sz="800" b="0" i="0">
+              <a:rPr sz="750" b="0" i="0">
                 <a:solidFill>
                   <a:srgbClr val="0F172A"/>
                 </a:solidFill>
@@ -33285,13 +33382,13 @@
       </p:sp>
       <p:sp>
         <p:nvSpPr>
-          <p:cNvPr id="20" name="Oval 19"/>
+          <p:cNvPr id="22" name="Oval 21"/>
           <p:cNvSpPr/>
           <p:nvPr/>
         </p:nvSpPr>
         <p:spPr>
           <a:xfrm>
-            <a:off x="8565642" y="1325880"/>
+            <a:off x="8856472" y="1325880"/>
             <a:ext cx="310896" cy="310896"/>
           </a:xfrm>
           <a:prstGeom prst="ellipse">
@@ -33337,21 +33434,21 @@
                 </a:solidFill>
                 <a:latin typeface="Arial"/>
               </a:rPr>
-              <a:t>7</a:t>
+              <a:t>8</a:t>
             </a:r>
           </a:p>
         </p:txBody>
       </p:sp>
       <p:sp>
         <p:nvSpPr>
-          <p:cNvPr id="21" name="TextBox 20"/>
+          <p:cNvPr id="23" name="TextBox 22"/>
           <p:cNvSpPr txBox="1"/>
           <p:nvPr/>
         </p:nvSpPr>
         <p:spPr>
           <a:xfrm>
-            <a:off x="8117586" y="1737360"/>
-            <a:ext cx="1207008" cy="548640"/>
+            <a:off x="8463280" y="1737360"/>
+            <a:ext cx="1097280" cy="548640"/>
           </a:xfrm>
           <a:prstGeom prst="rect">
             <a:avLst/>
@@ -33369,7 +33466,7 @@
               <a:buNone/>
             </a:pPr>
             <a:r>
-              <a:rPr sz="800" b="0" i="0">
+              <a:rPr sz="750" b="0" i="0">
                 <a:solidFill>
                   <a:srgbClr val="0F172A"/>
                 </a:solidFill>
@@ -33382,13 +33479,13 @@
       </p:sp>
       <p:sp>
         <p:nvSpPr>
-          <p:cNvPr id="22" name="Oval 21"/>
+          <p:cNvPr id="24" name="Oval 23"/>
           <p:cNvSpPr/>
           <p:nvPr/>
         </p:nvSpPr>
         <p:spPr>
           <a:xfrm>
-            <a:off x="9874377" y="1325880"/>
+            <a:off x="10019792" y="1325880"/>
             <a:ext cx="310896" cy="310896"/>
           </a:xfrm>
           <a:prstGeom prst="ellipse">
@@ -33434,21 +33531,21 @@
                 </a:solidFill>
                 <a:latin typeface="Arial"/>
               </a:rPr>
-              <a:t>8</a:t>
+              <a:t>9</a:t>
             </a:r>
           </a:p>
         </p:txBody>
       </p:sp>
       <p:sp>
         <p:nvSpPr>
-          <p:cNvPr id="23" name="TextBox 22"/>
+          <p:cNvPr id="25" name="TextBox 24"/>
           <p:cNvSpPr txBox="1"/>
           <p:nvPr/>
         </p:nvSpPr>
         <p:spPr>
           <a:xfrm>
-            <a:off x="9426321" y="1737360"/>
-            <a:ext cx="1207008" cy="548640"/>
+            <a:off x="9626600" y="1737360"/>
+            <a:ext cx="1097280" cy="548640"/>
           </a:xfrm>
           <a:prstGeom prst="rect">
             <a:avLst/>
@@ -33466,7 +33563,7 @@
               <a:buNone/>
             </a:pPr>
             <a:r>
-              <a:rPr sz="800" b="0" i="0">
+              <a:rPr sz="750" b="0" i="0">
                 <a:solidFill>
                   <a:srgbClr val="0F172A"/>
                 </a:solidFill>
@@ -33479,7 +33576,7 @@
       </p:sp>
       <p:sp>
         <p:nvSpPr>
-          <p:cNvPr id="24" name="Oval 23"/>
+          <p:cNvPr id="26" name="Oval 25"/>
           <p:cNvSpPr/>
           <p:nvPr/>
         </p:nvSpPr>
@@ -33531,21 +33628,21 @@
                 </a:solidFill>
                 <a:latin typeface="Arial"/>
               </a:rPr>
-              <a:t>9</a:t>
+              <a:t>10</a:t>
             </a:r>
           </a:p>
         </p:txBody>
       </p:sp>
       <p:sp>
         <p:nvSpPr>
-          <p:cNvPr id="25" name="TextBox 24"/>
+          <p:cNvPr id="27" name="TextBox 26"/>
           <p:cNvSpPr txBox="1"/>
           <p:nvPr/>
         </p:nvSpPr>
         <p:spPr>
           <a:xfrm>
-            <a:off x="10735056" y="1737360"/>
-            <a:ext cx="1207008" cy="548640"/>
+            <a:off x="10789920" y="1737360"/>
+            <a:ext cx="1097280" cy="548640"/>
           </a:xfrm>
           <a:prstGeom prst="rect">
             <a:avLst/>
@@ -33563,20 +33660,20 @@
               <a:buNone/>
             </a:pPr>
             <a:r>
-              <a:rPr sz="800" b="0" i="0">
+              <a:rPr sz="750" b="0" i="0">
                 <a:solidFill>
                   <a:srgbClr val="0F172A"/>
                 </a:solidFill>
                 <a:latin typeface="Arial"/>
               </a:rPr>
-              <a:t>Test it with real water</a:t>
+              <a:t>Test the full capsule</a:t>
             </a:r>
           </a:p>
         </p:txBody>
       </p:sp>
       <p:sp>
         <p:nvSpPr>
-          <p:cNvPr id="26" name="Rounded Rectangle 25"/>
+          <p:cNvPr id="28" name="Rounded Rectangle 27"/>
           <p:cNvSpPr/>
           <p:nvPr/>
         </p:nvSpPr>
@@ -33635,7 +33732,7 @@
       </p:sp>
       <p:sp>
         <p:nvSpPr>
-          <p:cNvPr id="27" name="Rounded Rectangle 26"/>
+          <p:cNvPr id="29" name="Rounded Rectangle 28"/>
           <p:cNvSpPr/>
           <p:nvPr/>
         </p:nvSpPr>
@@ -33694,7 +33791,7 @@
       </p:sp>
       <p:sp>
         <p:nvSpPr>
-          <p:cNvPr id="28" name="Rounded Rectangle 27"/>
+          <p:cNvPr id="30" name="Rounded Rectangle 29"/>
           <p:cNvSpPr/>
           <p:nvPr/>
         </p:nvSpPr>
@@ -33753,7 +33850,7 @@
       </p:sp>
       <p:sp>
         <p:nvSpPr>
-          <p:cNvPr id="29" name="Rounded Rectangle 28"/>
+          <p:cNvPr id="31" name="Rounded Rectangle 30"/>
           <p:cNvSpPr/>
           <p:nvPr/>
         </p:nvSpPr>
@@ -33799,7 +33896,7 @@
       </p:sp>
       <p:pic>
         <p:nvPicPr>
-          <p:cNvPr id="30" name="Picture 29" descr="image.png"/>
+          <p:cNvPr id="32" name="Picture 31" descr="image.png"/>
           <p:cNvPicPr>
             <a:picLocks noChangeAspect="1"/>
           </p:cNvPicPr>
@@ -33823,7 +33920,7 @@
       </p:pic>
       <p:sp>
         <p:nvSpPr>
-          <p:cNvPr id="31" name="TextBox 30"/>
+          <p:cNvPr id="33" name="TextBox 32"/>
           <p:cNvSpPr txBox="1"/>
           <p:nvPr/>
         </p:nvSpPr>
@@ -33861,7 +33958,7 @@
       </p:sp>
       <p:sp>
         <p:nvSpPr>
-          <p:cNvPr id="32" name="TextBox 31"/>
+          <p:cNvPr id="34" name="TextBox 33"/>
           <p:cNvSpPr txBox="1"/>
           <p:nvPr/>
         </p:nvSpPr>
@@ -34037,7 +34134,7 @@
       </p:sp>
       <p:sp>
         <p:nvSpPr>
-          <p:cNvPr id="33" name="Rounded Rectangle 32"/>
+          <p:cNvPr id="35" name="Rounded Rectangle 34"/>
           <p:cNvSpPr/>
           <p:nvPr/>
         </p:nvSpPr>
@@ -34083,7 +34180,7 @@
       </p:sp>
       <p:pic>
         <p:nvPicPr>
-          <p:cNvPr id="34" name="Picture 33" descr="image.png"/>
+          <p:cNvPr id="36" name="Picture 35" descr="image.png"/>
           <p:cNvPicPr>
             <a:picLocks noChangeAspect="1"/>
           </p:cNvPicPr>
@@ -34107,7 +34204,7 @@
       </p:pic>
       <p:sp>
         <p:nvSpPr>
-          <p:cNvPr id="35" name="TextBox 34"/>
+          <p:cNvPr id="37" name="TextBox 36"/>
           <p:cNvSpPr txBox="1"/>
           <p:nvPr/>
         </p:nvSpPr>
@@ -34145,7 +34242,7 @@
       </p:sp>
       <p:sp>
         <p:nvSpPr>
-          <p:cNvPr id="36" name="TextBox 35"/>
+          <p:cNvPr id="38" name="TextBox 37"/>
           <p:cNvSpPr txBox="1"/>
           <p:nvPr/>
         </p:nvSpPr>
@@ -34225,7 +34322,7 @@
                 </a:solidFill>
                 <a:latin typeface="Arial"/>
               </a:rPr>
-              <a:t>All the design files are in our public repository. There are no build photos or test logs yet.</a:t>
+              <a:t>We have wired the pH, TDS and turbidity sensors to an ESP32 board on a breadboard and tried them in water (photos on slide 13). We haven’t logged any measured results yet.</a:t>
             </a:r>
           </a:p>
           <a:p>
@@ -34247,14 +34344,14 @@
                 </a:solidFill>
                 <a:latin typeface="Arial"/>
               </a:rPr>
-              <a:t>Steps 6 to 9 (code, build and testing) haven’t started.</a:t>
+              <a:t>Steps 7 to 10 (code, building the capsule and full testing) are still ahead of us.</a:t>
             </a:r>
           </a:p>
         </p:txBody>
       </p:sp>
       <p:pic>
         <p:nvPicPr>
-          <p:cNvPr id="37" name="Note bar" descr="image.png"/>
+          <p:cNvPr id="39" name="Note bar" descr="image.png"/>
           <p:cNvPicPr>
             <a:picLocks noChangeAspect="1"/>
           </p:cNvPicPr>
@@ -34278,7 +34375,7 @@
       </p:pic>
       <p:sp>
         <p:nvSpPr>
-          <p:cNvPr id="38" name="Note text"/>
+          <p:cNvPr id="40" name="Note text"/>
           <p:cNvSpPr txBox="1"/>
           <p:nvPr/>
         </p:nvSpPr>
@@ -34318,7 +34415,7 @@
                 </a:solidFill>
                 <a:latin typeface="Arial"/>
               </a:rPr>
-              <a:t> the design files exist (step 5). We haven’t built any hardware yet, and we aren’t claiming any test results.</a:t>
+              <a:t> the design files exist and our sensors are running on a bench setup (steps 5 and 6). The capsule itself isn’t built yet, and we aren’t claiming test results.</a:t>
             </a:r>
           </a:p>
         </p:txBody>
@@ -34601,7 +34698,7 @@
                 </a:solidFill>
                 <a:latin typeface="Arial"/>
               </a:rPr>
-              <a:t>Photos of us building it</a:t>
+              <a:t>Our first bench session</a:t>
             </a:r>
           </a:p>
         </p:txBody>
@@ -34614,8 +34711,8 @@
         </p:nvSpPr>
         <p:spPr>
           <a:xfrm>
-            <a:off x="697687" y="1325880"/>
-            <a:ext cx="2971800" cy="1463040"/>
+            <a:off x="697687" y="1298448"/>
+            <a:ext cx="2971800" cy="274320"/>
           </a:xfrm>
           <a:prstGeom prst="rect">
             <a:avLst/>
@@ -34628,7 +34725,7 @@
           <a:p>
             <a:pPr algn="l">
               <a:spcAft>
-                <a:spcPts val="400"/>
+                <a:spcPts val="300"/>
               </a:spcAft>
               <a:buNone/>
             </a:pPr>
@@ -34639,236 +34736,138 @@
                 </a:solidFill>
                 <a:latin typeface="Arial"/>
               </a:rPr>
-              <a:t>To show we really made it ourselves</a:t>
-            </a:r>
-          </a:p>
-          <a:p>
-            <a:pPr algn="l" marL="128016" indent="-128016">
+              <a:t>Real photos from our own bench work</a:t>
+            </a:r>
+          </a:p>
+        </p:txBody>
+      </p:sp>
+      <p:pic>
+        <p:nvPicPr>
+          <p:cNvPr id="11" name="Photo: bench wiring" descr="Team bench setup: ESP32 board wired to pH, TDS and turbidity sensor boards on a breadboard"/>
+          <p:cNvPicPr>
+            <a:picLocks noChangeAspect="1"/>
+          </p:cNvPicPr>
+          <p:nvPr/>
+        </p:nvPicPr>
+        <p:blipFill>
+          <a:blip r:embed="rId6"/>
+          <a:stretch>
+            <a:fillRect/>
+          </a:stretch>
+        </p:blipFill>
+        <p:spPr>
+          <a:xfrm>
+            <a:off x="697687" y="1572768"/>
+            <a:ext cx="2971800" cy="1669316"/>
+          </a:xfrm>
+          <a:prstGeom prst="rect">
+            <a:avLst/>
+          </a:prstGeom>
+        </p:spPr>
+      </p:pic>
+      <p:sp>
+        <p:nvSpPr>
+          <p:cNvPr id="12" name="TextBox 11"/>
+          <p:cNvSpPr txBox="1"/>
+          <p:nvPr/>
+        </p:nvSpPr>
+        <p:spPr>
+          <a:xfrm>
+            <a:off x="697687" y="3264408"/>
+            <a:ext cx="2971800" cy="329184"/>
+          </a:xfrm>
+          <a:prstGeom prst="rect">
+            <a:avLst/>
+          </a:prstGeom>
+          <a:noFill/>
+        </p:spPr>
+        <p:txBody>
+          <a:bodyPr wrap="square" lIns="0" rIns="0" tIns="0" bIns="0" anchor="t"/>
+          <a:lstStyle/>
+          <a:p>
+            <a:pPr algn="ctr">
               <a:spcAft>
                 <a:spcPts val="300"/>
               </a:spcAft>
-              <a:buClr>
-                <a:srgbClr val="059668"/>
-              </a:buClr>
-              <a:buSzPct val="100000"/>
-              <a:buFont typeface="Arial"/>
-              <a:buChar char="▪"/>
+              <a:buNone/>
             </a:pPr>
             <a:r>
-              <a:rPr sz="850" b="0" i="0">
-                <a:solidFill>
-                  <a:srgbClr val="334155"/>
-                </a:solidFill>
-                <a:latin typeface="Arial"/>
-              </a:rPr>
-              <a:t>Us printing the body, putting the water parts together and calibrating the test cell</a:t>
-            </a:r>
-          </a:p>
-          <a:p>
-            <a:pPr algn="l" marL="128016" indent="-128016">
+              <a:rPr sz="750" b="0" i="1">
+                <a:solidFill>
+                  <a:srgbClr val="64748B"/>
+                </a:solidFill>
+                <a:latin typeface="Arial"/>
+              </a:rPr>
+              <a:t>Our ESP32 board wired to the pH, TDS and turbidity sensors on a breadboard</a:t>
+            </a:r>
+          </a:p>
+        </p:txBody>
+      </p:sp>
+      <p:pic>
+        <p:nvPicPr>
+          <p:cNvPr id="13" name="Photo: sensors in water" descr="Team member placing the pH probe and turbidity sensor in a water sample"/>
+          <p:cNvPicPr>
+            <a:picLocks noChangeAspect="1"/>
+          </p:cNvPicPr>
+          <p:nvPr/>
+        </p:nvPicPr>
+        <p:blipFill>
+          <a:blip r:embed="rId7"/>
+          <a:stretch>
+            <a:fillRect/>
+          </a:stretch>
+        </p:blipFill>
+        <p:spPr>
+          <a:xfrm>
+            <a:off x="697687" y="3611880"/>
+            <a:ext cx="2971800" cy="1666297"/>
+          </a:xfrm>
+          <a:prstGeom prst="rect">
+            <a:avLst/>
+          </a:prstGeom>
+        </p:spPr>
+      </p:pic>
+      <p:sp>
+        <p:nvSpPr>
+          <p:cNvPr id="14" name="TextBox 13"/>
+          <p:cNvSpPr txBox="1"/>
+          <p:nvPr/>
+        </p:nvSpPr>
+        <p:spPr>
+          <a:xfrm>
+            <a:off x="697687" y="5303520"/>
+            <a:ext cx="2971800" cy="228600"/>
+          </a:xfrm>
+          <a:prstGeom prst="rect">
+            <a:avLst/>
+          </a:prstGeom>
+          <a:noFill/>
+        </p:spPr>
+        <p:txBody>
+          <a:bodyPr wrap="square" lIns="0" rIns="0" tIns="0" bIns="0" anchor="t"/>
+          <a:lstStyle/>
+          <a:p>
+            <a:pPr algn="ctr">
               <a:spcAft>
                 <a:spcPts val="300"/>
               </a:spcAft>
-              <a:buClr>
-                <a:srgbClr val="059668"/>
-              </a:buClr>
-              <a:buSzPct val="100000"/>
-              <a:buFont typeface="Arial"/>
-              <a:buChar char="▪"/>
+              <a:buNone/>
             </a:pPr>
             <a:r>
-              <a:rPr sz="850" b="0" i="0">
-                <a:solidFill>
-                  <a:srgbClr val="334155"/>
-                </a:solidFill>
-                <a:latin typeface="Arial"/>
-              </a:rPr>
-              <a:t>With our college ID badges visible</a:t>
-            </a:r>
-          </a:p>
-          <a:p>
-            <a:pPr algn="l" marL="128016" indent="-128016">
-              <a:spcAft>
-                <a:spcPts val="300"/>
-              </a:spcAft>
-              <a:buClr>
-                <a:srgbClr val="059668"/>
-              </a:buClr>
-              <a:buSzPct val="100000"/>
-              <a:buFont typeface="Arial"/>
-              <a:buChar char="▪"/>
-            </a:pPr>
-            <a:r>
-              <a:rPr sz="850" b="0" i="0">
-                <a:solidFill>
-                  <a:srgbClr val="334155"/>
-                </a:solidFill>
-                <a:latin typeface="Arial"/>
-              </a:rPr>
-              <a:t>A photo with our faculty mentor, if we have one</a:t>
+              <a:rPr sz="750" b="0" i="1">
+                <a:solidFill>
+                  <a:srgbClr val="64748B"/>
+                </a:solidFill>
+                <a:latin typeface="Arial"/>
+              </a:rPr>
+              <a:t>Trying the pH probe and turbidity sensor in a water sample</a:t>
             </a:r>
           </a:p>
         </p:txBody>
       </p:sp>
       <p:sp>
         <p:nvSpPr>
-          <p:cNvPr id="11" name="Rounded Rectangle 10"/>
-          <p:cNvSpPr/>
-          <p:nvPr/>
-        </p:nvSpPr>
-        <p:spPr>
-          <a:xfrm>
-            <a:off x="697687" y="2971800"/>
-            <a:ext cx="2971800" cy="1170432"/>
-          </a:xfrm>
-          <a:prstGeom prst="roundRect">
-            <a:avLst>
-              <a:gd name="adj" fmla="val 4687"/>
-            </a:avLst>
-          </a:prstGeom>
-          <a:solidFill>
-            <a:srgbClr val="FFFFFF"/>
-          </a:solidFill>
-          <a:ln w="9525">
-            <a:solidFill>
-              <a:srgbClr val="94A3B8"/>
-            </a:solidFill>
-            <a:prstDash val="dash"/>
-          </a:ln>
-          <a:effectLst/>
-        </p:spPr>
-        <p:style>
-          <a:lnRef idx="1">
-            <a:schemeClr val="accent1"/>
-          </a:lnRef>
-          <a:fillRef idx="3">
-            <a:schemeClr val="accent1"/>
-          </a:fillRef>
-          <a:effectRef idx="2">
-            <a:schemeClr val="accent1"/>
-          </a:effectRef>
-          <a:fontRef idx="minor">
-            <a:schemeClr val="lt1"/>
-          </a:fontRef>
-        </p:style>
-        <p:txBody>
-          <a:bodyPr rtlCol="0" anchor="ctr" wrap="square" lIns="54864" rIns="54864" tIns="27432" bIns="27432"/>
-          <a:lstStyle/>
-          <a:p>
-            <a:pPr algn="ctr">
-              <a:spcAft>
-                <a:spcPts val="0"/>
-              </a:spcAft>
-            </a:pPr>
-            <a:r>
-              <a:rPr sz="850" b="1" i="0">
-                <a:solidFill>
-                  <a:srgbClr val="64748B"/>
-                </a:solidFill>
-                <a:latin typeface="Arial"/>
-              </a:rPr>
-              <a:t>Photo: assembling the water parts</a:t>
-            </a:r>
-          </a:p>
-          <a:p>
-            <a:pPr algn="ctr">
-              <a:spcAft>
-                <a:spcPts val="0"/>
-              </a:spcAft>
-            </a:pPr>
-            <a:r>
-              <a:rPr sz="750" b="0" i="1">
-                <a:solidFill>
-                  <a:srgbClr val="B45309"/>
-                </a:solidFill>
-                <a:latin typeface="Arial"/>
-              </a:rPr>
-              <a:t>We will take this during the build in Month 2. It has to be a real photo of us.</a:t>
-            </a:r>
-          </a:p>
-        </p:txBody>
-      </p:sp>
-      <p:sp>
-        <p:nvSpPr>
-          <p:cNvPr id="12" name="Rounded Rectangle 11"/>
-          <p:cNvSpPr/>
-          <p:nvPr/>
-        </p:nvSpPr>
-        <p:spPr>
-          <a:xfrm>
-            <a:off x="697687" y="4251960"/>
-            <a:ext cx="2971800" cy="1170432"/>
-          </a:xfrm>
-          <a:prstGeom prst="roundRect">
-            <a:avLst>
-              <a:gd name="adj" fmla="val 4687"/>
-            </a:avLst>
-          </a:prstGeom>
-          <a:solidFill>
-            <a:srgbClr val="FFFFFF"/>
-          </a:solidFill>
-          <a:ln w="9525">
-            <a:solidFill>
-              <a:srgbClr val="94A3B8"/>
-            </a:solidFill>
-            <a:prstDash val="dash"/>
-          </a:ln>
-          <a:effectLst/>
-        </p:spPr>
-        <p:style>
-          <a:lnRef idx="1">
-            <a:schemeClr val="accent1"/>
-          </a:lnRef>
-          <a:fillRef idx="3">
-            <a:schemeClr val="accent1"/>
-          </a:fillRef>
-          <a:effectRef idx="2">
-            <a:schemeClr val="accent1"/>
-          </a:effectRef>
-          <a:fontRef idx="minor">
-            <a:schemeClr val="lt1"/>
-          </a:fontRef>
-        </p:style>
-        <p:txBody>
-          <a:bodyPr rtlCol="0" anchor="ctr" wrap="square" lIns="54864" rIns="54864" tIns="27432" bIns="27432"/>
-          <a:lstStyle/>
-          <a:p>
-            <a:pPr algn="ctr">
-              <a:spcAft>
-                <a:spcPts val="0"/>
-              </a:spcAft>
-            </a:pPr>
-            <a:r>
-              <a:rPr sz="850" b="1" i="0">
-                <a:solidFill>
-                  <a:srgbClr val="64748B"/>
-                </a:solidFill>
-                <a:latin typeface="Arial"/>
-              </a:rPr>
-              <a:t>Photo: calibrating the test cell</a:t>
-            </a:r>
-          </a:p>
-          <a:p>
-            <a:pPr algn="ctr">
-              <a:spcAft>
-                <a:spcPts val="0"/>
-              </a:spcAft>
-            </a:pPr>
-            <a:r>
-              <a:rPr sz="750" b="0" i="1">
-                <a:solidFill>
-                  <a:srgbClr val="B45309"/>
-                </a:solidFill>
-                <a:latin typeface="Arial"/>
-              </a:rPr>
-              <a:t>We will take this during the build in Month 2. It has to be a real photo of us.</a:t>
-            </a:r>
-          </a:p>
-        </p:txBody>
-      </p:sp>
-      <p:sp>
-        <p:nvSpPr>
-          <p:cNvPr id="13" name="Rounded Rectangle 12"/>
+          <p:cNvPr id="15" name="Rounded Rectangle 14"/>
           <p:cNvSpPr/>
           <p:nvPr/>
         </p:nvSpPr>
@@ -34914,131 +34913,7 @@
       </p:sp>
       <p:pic>
         <p:nvPicPr>
-          <p:cNvPr id="14" name="Picture 13" descr="image.png"/>
-          <p:cNvPicPr>
-            <a:picLocks noChangeAspect="1"/>
-          </p:cNvPicPr>
-          <p:nvPr/>
-        </p:nvPicPr>
-        <p:blipFill>
-          <a:blip r:embed="rId6"/>
-          <a:stretch>
-            <a:fillRect/>
-          </a:stretch>
-        </p:blipFill>
-        <p:spPr>
-          <a:xfrm>
-            <a:off x="4114800" y="1115568"/>
-            <a:ext cx="153296" cy="173736"/>
-          </a:xfrm>
-          <a:prstGeom prst="rect">
-            <a:avLst/>
-          </a:prstGeom>
-        </p:spPr>
-      </p:pic>
-      <p:sp>
-        <p:nvSpPr>
-          <p:cNvPr id="15" name="TextBox 14"/>
-          <p:cNvSpPr txBox="1"/>
-          <p:nvPr/>
-        </p:nvSpPr>
-        <p:spPr>
-          <a:xfrm>
-            <a:off x="4370832" y="1078992"/>
-            <a:ext cx="3794759" cy="274320"/>
-          </a:xfrm>
-          <a:prstGeom prst="rect">
-            <a:avLst/>
-          </a:prstGeom>
-          <a:noFill/>
-        </p:spPr>
-        <p:txBody>
-          <a:bodyPr wrap="square" lIns="0" rIns="0" tIns="0" bIns="0" anchor="t"/>
-          <a:lstStyle/>
-          <a:p>
-            <a:pPr algn="l">
-              <a:spcAft>
-                <a:spcPts val="300"/>
-              </a:spcAft>
-              <a:buNone/>
-            </a:pPr>
-            <a:r>
-              <a:rPr sz="1100" b="1" i="0">
-                <a:solidFill>
-                  <a:srgbClr val="0F172A"/>
-                </a:solidFill>
-                <a:latin typeface="Arial"/>
-              </a:rPr>
-              <a:t>Our design work so far</a:t>
-            </a:r>
-          </a:p>
-        </p:txBody>
-      </p:sp>
-      <p:pic>
-        <p:nvPicPr>
-          <p:cNvPr id="16" name="FreeCAD screenshot" descr="freecad_model_tree.png"/>
-          <p:cNvPicPr>
-            <a:picLocks noChangeAspect="1"/>
-          </p:cNvPicPr>
-          <p:nvPr/>
-        </p:nvPicPr>
-        <p:blipFill>
-          <a:blip r:embed="rId7"/>
-          <a:stretch>
-            <a:fillRect/>
-          </a:stretch>
-        </p:blipFill>
-        <p:spPr>
-          <a:xfrm>
-            <a:off x="4114800" y="1325880"/>
-            <a:ext cx="4032504" cy="2211170"/>
-          </a:xfrm>
-          <a:prstGeom prst="rect">
-            <a:avLst/>
-          </a:prstGeom>
-        </p:spPr>
-      </p:pic>
-      <p:sp>
-        <p:nvSpPr>
-          <p:cNvPr id="17" name="TextBox 16"/>
-          <p:cNvSpPr txBox="1"/>
-          <p:nvPr/>
-        </p:nvSpPr>
-        <p:spPr>
-          <a:xfrm>
-            <a:off x="4114800" y="3502152"/>
-            <a:ext cx="4032504" cy="329184"/>
-          </a:xfrm>
-          <a:prstGeom prst="rect">
-            <a:avLst/>
-          </a:prstGeom>
-          <a:noFill/>
-        </p:spPr>
-        <p:txBody>
-          <a:bodyPr wrap="square" lIns="0" rIns="0" tIns="0" bIns="0" anchor="t"/>
-          <a:lstStyle/>
-          <a:p>
-            <a:pPr algn="ctr">
-              <a:spcAft>
-                <a:spcPts val="300"/>
-              </a:spcAft>
-              <a:buNone/>
-            </a:pPr>
-            <a:r>
-              <a:rPr sz="750" b="0" i="1">
-                <a:solidFill>
-                  <a:srgbClr val="64748B"/>
-                </a:solidFill>
-                <a:latin typeface="Arial"/>
-              </a:rPr>
-              <a:t>Our capsule in FreeCAD 1.1: 9 parts, with every key size driven by one parameter table</a:t>
-            </a:r>
-          </a:p>
-        </p:txBody>
-      </p:sp>
-      <p:pic>
-        <p:nvPicPr>
-          <p:cNvPr id="18" name="KiCad screenshot" descr="kicad_schematic_with_ERC.png"/>
+          <p:cNvPr id="16" name="Picture 15" descr="image.png"/>
           <p:cNvPicPr>
             <a:picLocks noChangeAspect="1"/>
           </p:cNvPicPr>
@@ -35052,8 +34927,70 @@
         </p:blipFill>
         <p:spPr>
           <a:xfrm>
-            <a:off x="4114800" y="3840480"/>
-            <a:ext cx="3200400" cy="1714146"/>
+            <a:off x="4114800" y="1115568"/>
+            <a:ext cx="153296" cy="173736"/>
+          </a:xfrm>
+          <a:prstGeom prst="rect">
+            <a:avLst/>
+          </a:prstGeom>
+        </p:spPr>
+      </p:pic>
+      <p:sp>
+        <p:nvSpPr>
+          <p:cNvPr id="17" name="TextBox 16"/>
+          <p:cNvSpPr txBox="1"/>
+          <p:nvPr/>
+        </p:nvSpPr>
+        <p:spPr>
+          <a:xfrm>
+            <a:off x="4370832" y="1078992"/>
+            <a:ext cx="3794759" cy="274320"/>
+          </a:xfrm>
+          <a:prstGeom prst="rect">
+            <a:avLst/>
+          </a:prstGeom>
+          <a:noFill/>
+        </p:spPr>
+        <p:txBody>
+          <a:bodyPr wrap="square" lIns="0" rIns="0" tIns="0" bIns="0" anchor="t"/>
+          <a:lstStyle/>
+          <a:p>
+            <a:pPr algn="l">
+              <a:spcAft>
+                <a:spcPts val="300"/>
+              </a:spcAft>
+              <a:buNone/>
+            </a:pPr>
+            <a:r>
+              <a:rPr sz="1100" b="1" i="0">
+                <a:solidFill>
+                  <a:srgbClr val="0F172A"/>
+                </a:solidFill>
+                <a:latin typeface="Arial"/>
+              </a:rPr>
+              <a:t>Our design work so far</a:t>
+            </a:r>
+          </a:p>
+        </p:txBody>
+      </p:sp>
+      <p:pic>
+        <p:nvPicPr>
+          <p:cNvPr id="18" name="FreeCAD screenshot" descr="freecad_model_tree.png"/>
+          <p:cNvPicPr>
+            <a:picLocks noChangeAspect="1"/>
+          </p:cNvPicPr>
+          <p:nvPr/>
+        </p:nvPicPr>
+        <p:blipFill>
+          <a:blip r:embed="rId9"/>
+          <a:stretch>
+            <a:fillRect/>
+          </a:stretch>
+        </p:blipFill>
+        <p:spPr>
+          <a:xfrm>
+            <a:off x="4114800" y="1325880"/>
+            <a:ext cx="4032504" cy="2211170"/>
           </a:xfrm>
           <a:prstGeom prst="rect">
             <a:avLst/>
@@ -35068,6 +35005,68 @@
         </p:nvSpPr>
         <p:spPr>
           <a:xfrm>
+            <a:off x="4114800" y="3502152"/>
+            <a:ext cx="4032504" cy="329184"/>
+          </a:xfrm>
+          <a:prstGeom prst="rect">
+            <a:avLst/>
+          </a:prstGeom>
+          <a:noFill/>
+        </p:spPr>
+        <p:txBody>
+          <a:bodyPr wrap="square" lIns="0" rIns="0" tIns="0" bIns="0" anchor="t"/>
+          <a:lstStyle/>
+          <a:p>
+            <a:pPr algn="ctr">
+              <a:spcAft>
+                <a:spcPts val="300"/>
+              </a:spcAft>
+              <a:buNone/>
+            </a:pPr>
+            <a:r>
+              <a:rPr sz="750" b="0" i="1">
+                <a:solidFill>
+                  <a:srgbClr val="64748B"/>
+                </a:solidFill>
+                <a:latin typeface="Arial"/>
+              </a:rPr>
+              <a:t>Our capsule in FreeCAD 1.1: 9 parts, with every key size driven by one parameter table</a:t>
+            </a:r>
+          </a:p>
+        </p:txBody>
+      </p:sp>
+      <p:pic>
+        <p:nvPicPr>
+          <p:cNvPr id="20" name="KiCad screenshot" descr="kicad_schematic_with_ERC.png"/>
+          <p:cNvPicPr>
+            <a:picLocks noChangeAspect="1"/>
+          </p:cNvPicPr>
+          <p:nvPr/>
+        </p:nvPicPr>
+        <p:blipFill>
+          <a:blip r:embed="rId10"/>
+          <a:stretch>
+            <a:fillRect/>
+          </a:stretch>
+        </p:blipFill>
+        <p:spPr>
+          <a:xfrm>
+            <a:off x="4114800" y="3840480"/>
+            <a:ext cx="3200400" cy="1714146"/>
+          </a:xfrm>
+          <a:prstGeom prst="rect">
+            <a:avLst/>
+          </a:prstGeom>
+        </p:spPr>
+      </p:pic>
+      <p:sp>
+        <p:nvSpPr>
+          <p:cNvPr id="21" name="TextBox 20"/>
+          <p:cNvSpPr txBox="1"/>
+          <p:nvPr/>
+        </p:nvSpPr>
+        <p:spPr>
+          <a:xfrm>
             <a:off x="7388352" y="3886200"/>
             <a:ext cx="822960" cy="1600200"/>
           </a:xfrm>
@@ -35100,7 +35099,7 @@
       </p:sp>
       <p:sp>
         <p:nvSpPr>
-          <p:cNvPr id="20" name="Rounded Rectangle 19"/>
+          <p:cNvPr id="22" name="Rounded Rectangle 21"/>
           <p:cNvSpPr/>
           <p:nvPr/>
         </p:nvSpPr>
@@ -35146,14 +35145,14 @@
       </p:sp>
       <p:pic>
         <p:nvPicPr>
-          <p:cNvPr id="21" name="Picture 20" descr="image.png"/>
+          <p:cNvPr id="23" name="Picture 22" descr="image.png"/>
           <p:cNvPicPr>
             <a:picLocks noChangeAspect="1"/>
           </p:cNvPicPr>
           <p:nvPr/>
         </p:nvPicPr>
         <p:blipFill>
-          <a:blip r:embed="rId9"/>
+          <a:blip r:embed="rId11"/>
           <a:stretch>
             <a:fillRect/>
           </a:stretch>
@@ -35170,7 +35169,7 @@
       </p:pic>
       <p:sp>
         <p:nvSpPr>
-          <p:cNvPr id="22" name="TextBox 21"/>
+          <p:cNvPr id="24" name="TextBox 23"/>
           <p:cNvSpPr txBox="1"/>
           <p:nvPr/>
         </p:nvSpPr>
@@ -35208,7 +35207,7 @@
       </p:sp>
       <p:sp>
         <p:nvSpPr>
-          <p:cNvPr id="23" name="Rounded Rectangle 22"/>
+          <p:cNvPr id="25" name="Rounded Rectangle 24"/>
           <p:cNvSpPr/>
           <p:nvPr/>
         </p:nvSpPr>
@@ -35285,7 +35284,7 @@
       </p:sp>
       <p:sp>
         <p:nvSpPr>
-          <p:cNvPr id="24" name="TextBox 23"/>
+          <p:cNvPr id="26" name="TextBox 25"/>
           <p:cNvSpPr txBox="1"/>
           <p:nvPr/>
         </p:nvSpPr>
@@ -35481,14 +35480,14 @@
       </p:sp>
       <p:pic>
         <p:nvPicPr>
-          <p:cNvPr id="25" name="Note bar" descr="image.png"/>
+          <p:cNvPr id="27" name="Note bar" descr="image.png"/>
           <p:cNvPicPr>
             <a:picLocks noChangeAspect="1"/>
           </p:cNvPicPr>
           <p:nvPr/>
         </p:nvPicPr>
         <p:blipFill>
-          <a:blip r:embed="rId10"/>
+          <a:blip r:embed="rId12"/>
           <a:stretch>
             <a:fillRect/>
           </a:stretch>
@@ -35505,7 +35504,7 @@
       </p:pic>
       <p:sp>
         <p:nvSpPr>
-          <p:cNvPr id="26" name="Note text"/>
+          <p:cNvPr id="28" name="Note text"/>
           <p:cNvSpPr txBox="1"/>
           <p:nvPr/>
         </p:nvSpPr>
@@ -35545,7 +35544,7 @@
                 </a:solidFill>
                 <a:latin typeface="Arial"/>
               </a:rPr>
-              <a:t> the CAD and schematic are real files made on 25 Oct 2026 with help from AI tools, and our team will review them. The photos must be real ones of us; none are made up.</a:t>
+              <a:t> the photos are from our own bench session; build photos with our ID badges will follow in Month 2. The CAD and schematic were made with help from AI tools, and we are reviewing them.</a:t>
             </a:r>
           </a:p>
         </p:txBody>
@@ -45391,7 +45390,7 @@
       </p:sp>
       <p:pic>
         <p:nvPicPr>
-          <p:cNvPr id="9" name="Picture 8" descr="cap_assembly_c.png"/>
+          <p:cNvPr id="9" name="Picture 8" descr="cap_exploded_c.png"/>
           <p:cNvPicPr>
             <a:picLocks noChangeAspect="1"/>
           </p:cNvPicPr>
@@ -45406,7 +45405,7 @@
         <p:spPr>
           <a:xfrm>
             <a:off x="548640" y="1792224"/>
-            <a:ext cx="475978" cy="640080"/>
+            <a:ext cx="407879" cy="640080"/>
           </a:xfrm>
           <a:prstGeom prst="rect">
             <a:avLst/>
@@ -45446,7 +45445,7 @@
                 </a:solidFill>
                 <a:latin typeface="Arial"/>
               </a:rPr>
-              <a:t>Slide 8: assembled capsule with numbered parts</a:t>
+              <a:t>Slide 8: assembled and exploded views with numbered parts</a:t>
             </a:r>
           </a:p>
           <a:p>
@@ -45463,14 +45462,14 @@
                 </a:solidFill>
                 <a:latin typeface="Arial"/>
               </a:rPr>
-              <a:t>The same illustration with labels added. Concept only.</a:t>
+              <a:t>The same illustration with labels added, and a taken-apart version. Concept only.</a:t>
             </a:r>
           </a:p>
         </p:txBody>
       </p:sp>
       <p:pic>
         <p:nvPicPr>
-          <p:cNvPr id="11" name="Picture 10" descr="cap_exploded_c.png"/>
+          <p:cNvPr id="11" name="Picture 10" descr="bench_wiring.jpg"/>
           <p:cNvPicPr>
             <a:picLocks noChangeAspect="1"/>
           </p:cNvPicPr>
@@ -45484,8 +45483,8 @@
         </p:blipFill>
         <p:spPr>
           <a:xfrm>
-            <a:off x="548640" y="2578608"/>
-            <a:ext cx="407879" cy="640080"/>
+            <a:off x="548640" y="2651760"/>
+            <a:ext cx="1143000" cy="642045"/>
           </a:xfrm>
           <a:prstGeom prst="rect">
             <a:avLst/>
@@ -45525,7 +45524,7 @@
                 </a:solidFill>
                 <a:latin typeface="Arial"/>
               </a:rPr>
-              <a:t>Slide 8: exploded view with numbered parts</a:t>
+              <a:t>Slide 13: bench session photos</a:t>
             </a:r>
           </a:p>
           <a:p>
@@ -45542,7 +45541,7 @@
                 </a:solidFill>
                 <a:latin typeface="Arial"/>
               </a:rPr>
-              <a:t>A taken-apart version of our illustration. Concept only.</a:t>
+              <a:t>Taken by our team during our own bench work with the sensors. The first photo was cropped to remove black borders; nothing else was edited.</a:t>
             </a:r>
           </a:p>
         </p:txBody>

</xml_diff>